<commit_message>
Update presentation_agent to use gpt-5.2 as default model and integrate ModelSettings for tool call configuration. Enhance numeric_highlight_slide with dynamic text sizing and optimal grid calculation for card layout.
</commit_message>
<xml_diff>
--- a/src/tests/test_numeric_highlight_slide.pptx
+++ b/src/tests/test_numeric_highlight_slide.pptx
@@ -3168,8 +3168,8 @@
         </p:nvSpPr>
         <p:spPr>
           <a:xfrm>
-            <a:off x="685800" y="2766060"/>
-            <a:ext cx="1805940" cy="1371600"/>
+            <a:off x="685800" y="2656332"/>
+            <a:ext cx="2468880" cy="1481328"/>
           </a:xfrm>
           <a:prstGeom prst="roundRect">
             <a:avLst/>
@@ -3203,7 +3203,7 @@
               <a:spcBef>
                 <a:spcPts val="600"/>
               </a:spcBef>
-              <a:defRPr sz="1100">
+              <a:defRPr sz="1500">
                 <a:solidFill>
                   <a:srgbClr val="333333"/>
                 </a:solidFill>
@@ -3216,7 +3216,7 @@
           </a:p>
           <a:p>
             <a:pPr algn="ctr">
-              <a:defRPr sz="2400" b="1">
+              <a:defRPr sz="3400" b="1">
                 <a:solidFill>
                   <a:srgbClr val="003366"/>
                 </a:solidFill>
@@ -3237,8 +3237,8 @@
         </p:nvSpPr>
         <p:spPr>
           <a:xfrm>
-            <a:off x="2674620" y="2766060"/>
-            <a:ext cx="1805940" cy="1371600"/>
+            <a:off x="3337560" y="2656332"/>
+            <a:ext cx="2468880" cy="1481328"/>
           </a:xfrm>
           <a:prstGeom prst="roundRect">
             <a:avLst/>
@@ -3272,7 +3272,7 @@
               <a:spcBef>
                 <a:spcPts val="600"/>
               </a:spcBef>
-              <a:defRPr sz="1100">
+              <a:defRPr sz="1500">
                 <a:solidFill>
                   <a:srgbClr val="333333"/>
                 </a:solidFill>
@@ -3285,7 +3285,7 @@
           </a:p>
           <a:p>
             <a:pPr algn="ctr">
-              <a:defRPr sz="2400" b="1">
+              <a:defRPr sz="3400" b="1">
                 <a:solidFill>
                   <a:srgbClr val="003366"/>
                 </a:solidFill>
@@ -3306,8 +3306,8 @@
         </p:nvSpPr>
         <p:spPr>
           <a:xfrm>
-            <a:off x="4663440" y="2766060"/>
-            <a:ext cx="1805940" cy="1371600"/>
+            <a:off x="5989320" y="2656332"/>
+            <a:ext cx="2468880" cy="1481328"/>
           </a:xfrm>
           <a:prstGeom prst="roundRect">
             <a:avLst/>
@@ -3341,7 +3341,7 @@
               <a:spcBef>
                 <a:spcPts val="600"/>
               </a:spcBef>
-              <a:defRPr sz="1100">
+              <a:defRPr sz="1500">
                 <a:solidFill>
                   <a:srgbClr val="333333"/>
                 </a:solidFill>
@@ -3354,7 +3354,7 @@
           </a:p>
           <a:p>
             <a:pPr algn="ctr">
-              <a:defRPr sz="2400" b="1">
+              <a:defRPr sz="3400" b="1">
                 <a:solidFill>
                   <a:srgbClr val="003366"/>
                 </a:solidFill>
@@ -3375,8 +3375,8 @@
         </p:nvSpPr>
         <p:spPr>
           <a:xfrm>
-            <a:off x="6652260" y="2766060"/>
-            <a:ext cx="1805940" cy="1371600"/>
+            <a:off x="685800" y="4320540"/>
+            <a:ext cx="2468880" cy="1481328"/>
           </a:xfrm>
           <a:prstGeom prst="roundRect">
             <a:avLst/>
@@ -3410,7 +3410,7 @@
               <a:spcBef>
                 <a:spcPts val="600"/>
               </a:spcBef>
-              <a:defRPr sz="1100">
+              <a:defRPr sz="1500">
                 <a:solidFill>
                   <a:srgbClr val="333333"/>
                 </a:solidFill>
@@ -3423,7 +3423,7 @@
           </a:p>
           <a:p>
             <a:pPr algn="ctr">
-              <a:defRPr sz="2400" b="1">
+              <a:defRPr sz="3400" b="1">
                 <a:solidFill>
                   <a:srgbClr val="003366"/>
                 </a:solidFill>
@@ -3444,8 +3444,8 @@
         </p:nvSpPr>
         <p:spPr>
           <a:xfrm>
-            <a:off x="685800" y="4320540"/>
-            <a:ext cx="1805940" cy="1371600"/>
+            <a:off x="3337560" y="4320540"/>
+            <a:ext cx="2468880" cy="1481328"/>
           </a:xfrm>
           <a:prstGeom prst="roundRect">
             <a:avLst/>
@@ -3479,7 +3479,7 @@
               <a:spcBef>
                 <a:spcPts val="600"/>
               </a:spcBef>
-              <a:defRPr sz="1100">
+              <a:defRPr sz="1500">
                 <a:solidFill>
                   <a:srgbClr val="333333"/>
                 </a:solidFill>
@@ -3487,12 +3487,12 @@
               </a:defRPr>
             </a:pPr>
             <a:r>
-              <a:t>R&amp;D Exp</a:t>
+              <a:t>Share Repurchase</a:t>
             </a:r>
           </a:p>
           <a:p>
             <a:pPr algn="ctr">
-              <a:defRPr sz="2400" b="1">
+              <a:defRPr sz="3400" b="1">
                 <a:solidFill>
                   <a:srgbClr val="003366"/>
                 </a:solidFill>
@@ -3500,7 +3500,7 @@
               </a:defRPr>
             </a:pPr>
             <a:r>
-              <a:t>$34.6 B</a:t>
+              <a:t>$90.7 B</a:t>
             </a:r>
           </a:p>
         </p:txBody>
@@ -3513,8 +3513,8 @@
         </p:nvSpPr>
         <p:spPr>
           <a:xfrm>
-            <a:off x="2674620" y="4320540"/>
-            <a:ext cx="1805940" cy="1371600"/>
+            <a:off x="5989320" y="4320540"/>
+            <a:ext cx="2468880" cy="1481328"/>
           </a:xfrm>
           <a:prstGeom prst="roundRect">
             <a:avLst/>
@@ -3548,7 +3548,7 @@
               <a:spcBef>
                 <a:spcPts val="600"/>
               </a:spcBef>
-              <a:defRPr sz="1100">
+              <a:defRPr sz="1500">
                 <a:solidFill>
                   <a:srgbClr val="333333"/>
                 </a:solidFill>
@@ -3556,12 +3556,12 @@
               </a:defRPr>
             </a:pPr>
             <a:r>
-              <a:t>Cash &amp; Securities</a:t>
+              <a:t>Term Debt</a:t>
             </a:r>
           </a:p>
           <a:p>
             <a:pPr algn="ctr">
-              <a:defRPr sz="2400" b="1">
+              <a:defRPr sz="3400" b="1">
                 <a:solidFill>
                   <a:srgbClr val="003366"/>
                 </a:solidFill>
@@ -3569,7 +3569,7 @@
               </a:defRPr>
             </a:pPr>
             <a:r>
-              <a:t>$132.4 B</a:t>
+              <a:t>$90.7 B</a:t>
             </a:r>
           </a:p>
         </p:txBody>

</xml_diff>